<commit_message>
make infographics semantic decision graphics
</commit_message>
<xml_diff>
--- a/artifacts/live-review/infographic-v6/infographic-v6.pptx
+++ b/artifacts/live-review/infographic-v6/infographic-v6.pptx
@@ -996,16 +996,39 @@
         </p:nvSpPr>
         <p:spPr>
           <a:xfrm>
-            <a:off x="841248" y="2176272"/>
-            <a:ext cx="10533888" cy="32004"/>
-          </a:xfrm>
-          <a:prstGeom prst="rect">
-            <a:avLst/>
-          </a:prstGeom>
-          <a:solidFill>
-            <a:srgbClr val="1668E3">
-              <a:alpha val="78000"/>
-            </a:srgbClr>
+            <a:off x="658368" y="1682496"/>
+            <a:ext cx="6748272" cy="1938528"/>
+          </a:xfrm>
+          <a:prstGeom prst="rect">
+            <a:avLst/>
+          </a:prstGeom>
+          <a:solidFill>
+            <a:srgbClr val="F4F2EC"/>
+          </a:solidFill>
+          <a:ln w="19050">
+            <a:solidFill>
+              <a:srgbClr val="1668E3"/>
+            </a:solidFill>
+            <a:prstDash val="solid"/>
+          </a:ln>
+        </p:spPr>
+      </p:sp>
+      <p:sp>
+        <p:nvSpPr>
+          <p:cNvPr id="6" name="Shape 4"/>
+          <p:cNvSpPr/>
+          <p:nvPr/>
+        </p:nvSpPr>
+        <p:spPr>
+          <a:xfrm>
+            <a:off x="658368" y="1682496"/>
+            <a:ext cx="6748272" cy="54864"/>
+          </a:xfrm>
+          <a:prstGeom prst="rect">
+            <a:avLst/>
+          </a:prstGeom>
+          <a:solidFill>
+            <a:srgbClr val="1668E3"/>
           </a:solidFill>
           <a:ln w="12700">
             <a:solidFill>
@@ -1019,14 +1042,14 @@
       </p:sp>
       <p:sp>
         <p:nvSpPr>
-          <p:cNvPr id="6" name="Shape 4"/>
-          <p:cNvSpPr/>
-          <p:nvPr/>
-        </p:nvSpPr>
-        <p:spPr>
-          <a:xfrm>
-            <a:off x="658368" y="1975104"/>
-            <a:ext cx="438912" cy="438912"/>
+          <p:cNvPr id="7" name="Shape 5"/>
+          <p:cNvSpPr/>
+          <p:nvPr/>
+        </p:nvSpPr>
+        <p:spPr>
+          <a:xfrm>
+            <a:off x="877824" y="1837944"/>
+            <a:ext cx="256032" cy="256032"/>
           </a:xfrm>
           <a:prstGeom prst="ellipse">
             <a:avLst/>
@@ -1034,9 +1057,11 @@
           <a:solidFill>
             <a:srgbClr val="1668E3"/>
           </a:solidFill>
-          <a:ln w="50800">
+          <a:ln w="12700">
             <a:solidFill>
-              <a:srgbClr val="F4F2EC"/>
+              <a:srgbClr val="1668E3">
+                <a:alpha val="0"/>
+              </a:srgbClr>
             </a:solidFill>
             <a:prstDash val="solid"/>
           </a:ln>
@@ -1044,14 +1069,14 @@
       </p:sp>
       <p:sp>
         <p:nvSpPr>
-          <p:cNvPr id="7" name="Text 5"/>
-          <p:cNvSpPr/>
-          <p:nvPr/>
-        </p:nvSpPr>
-        <p:spPr>
-          <a:xfrm>
-            <a:off x="658368" y="2093976"/>
-            <a:ext cx="438912" cy="118872"/>
+          <p:cNvPr id="8" name="Text 6"/>
+          <p:cNvSpPr/>
+          <p:nvPr/>
+        </p:nvSpPr>
+        <p:spPr>
+          <a:xfrm>
+            <a:off x="877824" y="1915668"/>
+            <a:ext cx="256032" cy="91440"/>
           </a:xfrm>
           <a:prstGeom prst="rect">
             <a:avLst/>
@@ -1067,7 +1092,7 @@
               <a:buNone/>
             </a:pPr>
             <a:r>
-              <a:rPr lang="en-US" sz="650" b="1" spc="80" kern="0" dirty="0">
+              <a:rPr lang="en-US" sz="480" b="1" spc="50" kern="0" dirty="0">
                 <a:solidFill>
                   <a:srgbClr val="FFFFFF"/>
                 </a:solidFill>
@@ -1077,20 +1102,20 @@
               </a:rPr>
               <a:t>01</a:t>
             </a:r>
-            <a:endParaRPr lang="en-US" sz="650" dirty="0"/>
-          </a:p>
-        </p:txBody>
-      </p:sp>
-      <p:sp>
-        <p:nvSpPr>
-          <p:cNvPr id="8" name="Text 6"/>
-          <p:cNvSpPr/>
-          <p:nvPr/>
-        </p:nvSpPr>
-        <p:spPr>
-          <a:xfrm>
-            <a:off x="3191256" y="2084832"/>
-            <a:ext cx="256032" cy="164592"/>
+            <a:endParaRPr lang="en-US" sz="480" dirty="0"/>
+          </a:p>
+        </p:txBody>
+      </p:sp>
+      <p:sp>
+        <p:nvSpPr>
+          <p:cNvPr id="9" name="Text 7"/>
+          <p:cNvSpPr/>
+          <p:nvPr/>
+        </p:nvSpPr>
+        <p:spPr>
+          <a:xfrm>
+            <a:off x="1243584" y="1915668"/>
+            <a:ext cx="5925312" cy="109728"/>
           </a:xfrm>
           <a:prstGeom prst="rect">
             <a:avLst/>
@@ -1102,34 +1127,34 @@
           <a:bodyPr wrap="square" lIns="0" tIns="0" rIns="0" bIns="0" rtlCol="0" anchor="ctr"/>
           <a:lstStyle/>
           <a:p>
-            <a:pPr algn="ctr" indent="0" marL="0">
+            <a:pPr indent="0" marL="0">
               <a:buNone/>
             </a:pPr>
             <a:r>
-              <a:rPr lang="en-US" sz="900" dirty="0">
+              <a:rPr lang="en-US" sz="650" b="1" spc="110" kern="0" dirty="0">
                 <a:solidFill>
-                  <a:srgbClr val="1668E3"/>
+                  <a:srgbClr val="171816"/>
                 </a:solidFill>
                 <a:latin typeface="Arial" pitchFamily="34" charset="0"/>
                 <a:ea typeface="Arial" pitchFamily="34" charset="-122"/>
                 <a:cs typeface="Arial" pitchFamily="34" charset="-120"/>
               </a:rPr>
-              <a:t>→</a:t>
-            </a:r>
-            <a:endParaRPr lang="en-US" sz="900" dirty="0"/>
-          </a:p>
-        </p:txBody>
-      </p:sp>
-      <p:sp>
-        <p:nvSpPr>
-          <p:cNvPr id="9" name="Text 7"/>
-          <p:cNvSpPr/>
-          <p:nvPr/>
-        </p:nvSpPr>
-        <p:spPr>
-          <a:xfrm>
-            <a:off x="658368" y="2761488"/>
-            <a:ext cx="2532888" cy="822960"/>
+              <a:t>KEY INSIGHT</a:t>
+            </a:r>
+            <a:endParaRPr lang="en-US" sz="650" dirty="0"/>
+          </a:p>
+        </p:txBody>
+      </p:sp>
+      <p:sp>
+        <p:nvSpPr>
+          <p:cNvPr id="10" name="Text 8"/>
+          <p:cNvSpPr/>
+          <p:nvPr/>
+        </p:nvSpPr>
+        <p:spPr>
+          <a:xfrm>
+            <a:off x="877824" y="2212848"/>
+            <a:ext cx="6309360" cy="658368"/>
           </a:xfrm>
           <a:prstGeom prst="rect">
             <a:avLst/>
@@ -1147,7 +1172,7 @@
               <a:buNone/>
             </a:pPr>
             <a:r>
-              <a:rPr lang="en-US" sz="1800" dirty="0">
+              <a:rPr lang="en-US" sz="1900" dirty="0">
                 <a:solidFill>
                   <a:srgbClr val="171816"/>
                 </a:solidFill>
@@ -1157,20 +1182,20 @@
               </a:rPr>
               <a:t>WorkshopLM turns messy meetings into professional knowledge work teams can defend</a:t>
             </a:r>
-            <a:endParaRPr lang="en-US" sz="1800" dirty="0"/>
-          </a:p>
-        </p:txBody>
-      </p:sp>
-      <p:sp>
-        <p:nvSpPr>
-          <p:cNvPr id="10" name="Text 8"/>
-          <p:cNvSpPr/>
-          <p:nvPr/>
-        </p:nvSpPr>
-        <p:spPr>
-          <a:xfrm>
-            <a:off x="658368" y="3785616"/>
-            <a:ext cx="2532888" cy="1143000"/>
+            <a:endParaRPr lang="en-US" sz="1900" dirty="0"/>
+          </a:p>
+        </p:txBody>
+      </p:sp>
+      <p:sp>
+        <p:nvSpPr>
+          <p:cNvPr id="11" name="Text 9"/>
+          <p:cNvSpPr/>
+          <p:nvPr/>
+        </p:nvSpPr>
+        <p:spPr>
+          <a:xfrm>
+            <a:off x="877824" y="2944368"/>
+            <a:ext cx="6309360" cy="365760"/>
           </a:xfrm>
           <a:prstGeom prst="rect">
             <a:avLst/>
@@ -1188,7 +1213,7 @@
               <a:buNone/>
             </a:pPr>
             <a:r>
-              <a:rPr lang="en-US" sz="1100" dirty="0">
+              <a:rPr lang="en-US" sz="1000" dirty="0">
                 <a:solidFill>
                   <a:srgbClr val="171816">
                     <a:alpha val="72000"/>
@@ -1200,20 +1225,20 @@
               </a:rPr>
               <a:t>with grounded source documents and brand rules preserving their standards</a:t>
             </a:r>
-            <a:endParaRPr lang="en-US" sz="1100" dirty="0"/>
-          </a:p>
-        </p:txBody>
-      </p:sp>
-      <p:sp>
-        <p:nvSpPr>
-          <p:cNvPr id="11" name="Text 9"/>
-          <p:cNvSpPr/>
-          <p:nvPr/>
-        </p:nvSpPr>
-        <p:spPr>
-          <a:xfrm>
-            <a:off x="658368" y="5907024"/>
-            <a:ext cx="2532888" cy="164592"/>
+            <a:endParaRPr lang="en-US" sz="1000" dirty="0"/>
+          </a:p>
+        </p:txBody>
+      </p:sp>
+      <p:sp>
+        <p:nvSpPr>
+          <p:cNvPr id="12" name="Text 10"/>
+          <p:cNvSpPr/>
+          <p:nvPr/>
+        </p:nvSpPr>
+        <p:spPr>
+          <a:xfrm>
+            <a:off x="877824" y="3401568"/>
+            <a:ext cx="6309360" cy="91440"/>
           </a:xfrm>
           <a:prstGeom prst="rect">
             <a:avLst/>
@@ -1231,7 +1256,7 @@
               <a:buNone/>
             </a:pPr>
             <a:r>
-              <a:rPr lang="en-US" sz="650" dirty="0">
+              <a:rPr lang="en-US" sz="520" dirty="0">
                 <a:solidFill>
                   <a:srgbClr val="171816">
                     <a:alpha val="58000"/>
@@ -1243,30 +1268,34 @@
               </a:rPr>
               <a:t>Source: Recorded fixture brainstorm</a:t>
             </a:r>
-            <a:endParaRPr lang="en-US" sz="650" dirty="0"/>
-          </a:p>
-        </p:txBody>
-      </p:sp>
-      <p:sp>
-        <p:nvSpPr>
-          <p:cNvPr id="12" name="Shape 10"/>
-          <p:cNvSpPr/>
-          <p:nvPr/>
-        </p:nvSpPr>
-        <p:spPr>
-          <a:xfrm>
-            <a:off x="3447288" y="1975104"/>
-            <a:ext cx="438912" cy="438912"/>
-          </a:xfrm>
-          <a:prstGeom prst="ellipse">
-            <a:avLst/>
-          </a:prstGeom>
-          <a:solidFill>
-            <a:srgbClr val="1668E3"/>
-          </a:solidFill>
-          <a:ln w="50800">
+            <a:endParaRPr lang="en-US" sz="520" dirty="0"/>
+          </a:p>
+        </p:txBody>
+      </p:sp>
+      <p:sp>
+        <p:nvSpPr>
+          <p:cNvPr id="13" name="Shape 11"/>
+          <p:cNvSpPr/>
+          <p:nvPr/>
+        </p:nvSpPr>
+        <p:spPr>
+          <a:xfrm>
+            <a:off x="7626096" y="1682496"/>
+            <a:ext cx="3922776" cy="1938528"/>
+          </a:xfrm>
+          <a:prstGeom prst="rect">
+            <a:avLst/>
+          </a:prstGeom>
+          <a:solidFill>
+            <a:srgbClr val="F4F2EC">
+              <a:alpha val="98000"/>
+            </a:srgbClr>
+          </a:solidFill>
+          <a:ln w="10160">
             <a:solidFill>
-              <a:srgbClr val="F4F2EC"/>
+              <a:srgbClr val="1668E3">
+                <a:alpha val="40000"/>
+              </a:srgbClr>
             </a:solidFill>
             <a:prstDash val="solid"/>
           </a:ln>
@@ -1274,14 +1303,41 @@
       </p:sp>
       <p:sp>
         <p:nvSpPr>
-          <p:cNvPr id="13" name="Text 11"/>
-          <p:cNvSpPr/>
-          <p:nvPr/>
-        </p:nvSpPr>
-        <p:spPr>
-          <a:xfrm>
-            <a:off x="3447288" y="2093976"/>
-            <a:ext cx="438912" cy="118872"/>
+          <p:cNvPr id="14" name="Shape 12"/>
+          <p:cNvSpPr/>
+          <p:nvPr/>
+        </p:nvSpPr>
+        <p:spPr>
+          <a:xfrm>
+            <a:off x="7845552" y="1837944"/>
+            <a:ext cx="256032" cy="256032"/>
+          </a:xfrm>
+          <a:prstGeom prst="ellipse">
+            <a:avLst/>
+          </a:prstGeom>
+          <a:solidFill>
+            <a:srgbClr val="1668E3"/>
+          </a:solidFill>
+          <a:ln w="12700">
+            <a:solidFill>
+              <a:srgbClr val="1668E3">
+                <a:alpha val="0"/>
+              </a:srgbClr>
+            </a:solidFill>
+            <a:prstDash val="solid"/>
+          </a:ln>
+        </p:spPr>
+      </p:sp>
+      <p:sp>
+        <p:nvSpPr>
+          <p:cNvPr id="15" name="Text 13"/>
+          <p:cNvSpPr/>
+          <p:nvPr/>
+        </p:nvSpPr>
+        <p:spPr>
+          <a:xfrm>
+            <a:off x="7845552" y="1915668"/>
+            <a:ext cx="256032" cy="91440"/>
           </a:xfrm>
           <a:prstGeom prst="rect">
             <a:avLst/>
@@ -1297,7 +1353,7 @@
               <a:buNone/>
             </a:pPr>
             <a:r>
-              <a:rPr lang="en-US" sz="650" b="1" spc="80" kern="0" dirty="0">
+              <a:rPr lang="en-US" sz="480" b="1" spc="50" kern="0" dirty="0">
                 <a:solidFill>
                   <a:srgbClr val="FFFFFF"/>
                 </a:solidFill>
@@ -1307,20 +1363,20 @@
               </a:rPr>
               <a:t>02</a:t>
             </a:r>
-            <a:endParaRPr lang="en-US" sz="650" dirty="0"/>
-          </a:p>
-        </p:txBody>
-      </p:sp>
-      <p:sp>
-        <p:nvSpPr>
-          <p:cNvPr id="14" name="Text 12"/>
-          <p:cNvSpPr/>
-          <p:nvPr/>
-        </p:nvSpPr>
-        <p:spPr>
-          <a:xfrm>
-            <a:off x="5980176" y="2084832"/>
-            <a:ext cx="256032" cy="164592"/>
+            <a:endParaRPr lang="en-US" sz="480" dirty="0"/>
+          </a:p>
+        </p:txBody>
+      </p:sp>
+      <p:sp>
+        <p:nvSpPr>
+          <p:cNvPr id="16" name="Text 14"/>
+          <p:cNvSpPr/>
+          <p:nvPr/>
+        </p:nvSpPr>
+        <p:spPr>
+          <a:xfrm>
+            <a:off x="8211312" y="1915668"/>
+            <a:ext cx="3099816" cy="109728"/>
           </a:xfrm>
           <a:prstGeom prst="rect">
             <a:avLst/>
@@ -1332,34 +1388,34 @@
           <a:bodyPr wrap="square" lIns="0" tIns="0" rIns="0" bIns="0" rtlCol="0" anchor="ctr"/>
           <a:lstStyle/>
           <a:p>
-            <a:pPr algn="ctr" indent="0" marL="0">
+            <a:pPr indent="0" marL="0">
               <a:buNone/>
             </a:pPr>
             <a:r>
-              <a:rPr lang="en-US" sz="900" dirty="0">
+              <a:rPr lang="en-US" sz="650" b="1" spc="110" kern="0" dirty="0">
                 <a:solidFill>
-                  <a:srgbClr val="1668E3"/>
+                  <a:srgbClr val="171816"/>
                 </a:solidFill>
                 <a:latin typeface="Arial" pitchFamily="34" charset="0"/>
                 <a:ea typeface="Arial" pitchFamily="34" charset="-122"/>
                 <a:cs typeface="Arial" pitchFamily="34" charset="-120"/>
               </a:rPr>
-              <a:t>→</a:t>
-            </a:r>
-            <a:endParaRPr lang="en-US" sz="900" dirty="0"/>
-          </a:p>
-        </p:txBody>
-      </p:sp>
-      <p:sp>
-        <p:nvSpPr>
-          <p:cNvPr id="15" name="Text 13"/>
-          <p:cNvSpPr/>
-          <p:nvPr/>
-        </p:nvSpPr>
-        <p:spPr>
-          <a:xfrm>
-            <a:off x="3447288" y="2761488"/>
-            <a:ext cx="2532888" cy="822960"/>
+              <a:t>CONTEXT</a:t>
+            </a:r>
+            <a:endParaRPr lang="en-US" sz="650" dirty="0"/>
+          </a:p>
+        </p:txBody>
+      </p:sp>
+      <p:sp>
+        <p:nvSpPr>
+          <p:cNvPr id="17" name="Text 15"/>
+          <p:cNvSpPr/>
+          <p:nvPr/>
+        </p:nvSpPr>
+        <p:spPr>
+          <a:xfrm>
+            <a:off x="7845552" y="2212848"/>
+            <a:ext cx="3483864" cy="658368"/>
           </a:xfrm>
           <a:prstGeom prst="rect">
             <a:avLst/>
@@ -1377,7 +1433,7 @@
               <a:buNone/>
             </a:pPr>
             <a:r>
-              <a:rPr lang="en-US" sz="1800" dirty="0">
+              <a:rPr lang="en-US" sz="1400" dirty="0">
                 <a:solidFill>
                   <a:srgbClr val="171816"/>
                 </a:solidFill>
@@ -1387,20 +1443,20 @@
               </a:rPr>
               <a:t>Creating client-ready work is slow and fragmented</a:t>
             </a:r>
-            <a:endParaRPr lang="en-US" sz="1800" dirty="0"/>
-          </a:p>
-        </p:txBody>
-      </p:sp>
-      <p:sp>
-        <p:nvSpPr>
-          <p:cNvPr id="16" name="Text 14"/>
-          <p:cNvSpPr/>
-          <p:nvPr/>
-        </p:nvSpPr>
-        <p:spPr>
-          <a:xfrm>
-            <a:off x="3447288" y="3785616"/>
-            <a:ext cx="2532888" cy="1143000"/>
+            <a:endParaRPr lang="en-US" sz="1400" dirty="0"/>
+          </a:p>
+        </p:txBody>
+      </p:sp>
+      <p:sp>
+        <p:nvSpPr>
+          <p:cNvPr id="18" name="Text 16"/>
+          <p:cNvSpPr/>
+          <p:nvPr/>
+        </p:nvSpPr>
+        <p:spPr>
+          <a:xfrm>
+            <a:off x="7845552" y="2944368"/>
+            <a:ext cx="3483864" cy="365760"/>
           </a:xfrm>
           <a:prstGeom prst="rect">
             <a:avLst/>
@@ -1418,7 +1474,7 @@
               <a:buNone/>
             </a:pPr>
             <a:r>
-              <a:rPr lang="en-US" sz="1100" dirty="0">
+              <a:rPr lang="en-US" sz="850" dirty="0">
                 <a:solidFill>
                   <a:srgbClr val="171816">
                     <a:alpha val="72000"/>
@@ -1430,20 +1486,20 @@
               </a:rPr>
               <a:t>because understanding, design, and production live in disconnected tools</a:t>
             </a:r>
-            <a:endParaRPr lang="en-US" sz="1100" dirty="0"/>
-          </a:p>
-        </p:txBody>
-      </p:sp>
-      <p:sp>
-        <p:nvSpPr>
-          <p:cNvPr id="17" name="Text 15"/>
-          <p:cNvSpPr/>
-          <p:nvPr/>
-        </p:nvSpPr>
-        <p:spPr>
-          <a:xfrm>
-            <a:off x="3447288" y="5907024"/>
-            <a:ext cx="2532888" cy="164592"/>
+            <a:endParaRPr lang="en-US" sz="850" dirty="0"/>
+          </a:p>
+        </p:txBody>
+      </p:sp>
+      <p:sp>
+        <p:nvSpPr>
+          <p:cNvPr id="19" name="Text 17"/>
+          <p:cNvSpPr/>
+          <p:nvPr/>
+        </p:nvSpPr>
+        <p:spPr>
+          <a:xfrm>
+            <a:off x="7845552" y="3401568"/>
+            <a:ext cx="3483864" cy="91440"/>
           </a:xfrm>
           <a:prstGeom prst="rect">
             <a:avLst/>
@@ -1461,7 +1517,7 @@
               <a:buNone/>
             </a:pPr>
             <a:r>
-              <a:rPr lang="en-US" sz="650" dirty="0">
+              <a:rPr lang="en-US" sz="520" dirty="0">
                 <a:solidFill>
                   <a:srgbClr val="171816">
                     <a:alpha val="58000"/>
@@ -1473,30 +1529,30 @@
               </a:rPr>
               <a:t>Source: Recorded fixture brainstorm</a:t>
             </a:r>
-            <a:endParaRPr lang="en-US" sz="650" dirty="0"/>
-          </a:p>
-        </p:txBody>
-      </p:sp>
-      <p:sp>
-        <p:nvSpPr>
-          <p:cNvPr id="18" name="Shape 16"/>
-          <p:cNvSpPr/>
-          <p:nvPr/>
-        </p:nvSpPr>
-        <p:spPr>
-          <a:xfrm>
-            <a:off x="6236208" y="1975104"/>
-            <a:ext cx="438912" cy="438912"/>
-          </a:xfrm>
-          <a:prstGeom prst="ellipse">
-            <a:avLst/>
-          </a:prstGeom>
-          <a:solidFill>
-            <a:srgbClr val="1668E3"/>
-          </a:solidFill>
-          <a:ln w="50800">
+            <a:endParaRPr lang="en-US" sz="520" dirty="0"/>
+          </a:p>
+        </p:txBody>
+      </p:sp>
+      <p:sp>
+        <p:nvSpPr>
+          <p:cNvPr id="20" name="Shape 18"/>
+          <p:cNvSpPr/>
+          <p:nvPr/>
+        </p:nvSpPr>
+        <p:spPr>
+          <a:xfrm>
+            <a:off x="658368" y="3767328"/>
+            <a:ext cx="3840480" cy="2139696"/>
+          </a:xfrm>
+          <a:prstGeom prst="rect">
+            <a:avLst/>
+          </a:prstGeom>
+          <a:solidFill>
+            <a:srgbClr val="171816"/>
+          </a:solidFill>
+          <a:ln w="10160">
             <a:solidFill>
-              <a:srgbClr val="F4F2EC"/>
+              <a:srgbClr val="171816"/>
             </a:solidFill>
             <a:prstDash val="solid"/>
           </a:ln>
@@ -1504,14 +1560,41 @@
       </p:sp>
       <p:sp>
         <p:nvSpPr>
-          <p:cNvPr id="19" name="Text 17"/>
-          <p:cNvSpPr/>
-          <p:nvPr/>
-        </p:nvSpPr>
-        <p:spPr>
-          <a:xfrm>
-            <a:off x="6236208" y="2093976"/>
-            <a:ext cx="438912" cy="118872"/>
+          <p:cNvPr id="21" name="Shape 19"/>
+          <p:cNvSpPr/>
+          <p:nvPr/>
+        </p:nvSpPr>
+        <p:spPr>
+          <a:xfrm>
+            <a:off x="877824" y="3922776"/>
+            <a:ext cx="256032" cy="256032"/>
+          </a:xfrm>
+          <a:prstGeom prst="ellipse">
+            <a:avLst/>
+          </a:prstGeom>
+          <a:solidFill>
+            <a:srgbClr val="1668E3"/>
+          </a:solidFill>
+          <a:ln w="12700">
+            <a:solidFill>
+              <a:srgbClr val="1668E3">
+                <a:alpha val="0"/>
+              </a:srgbClr>
+            </a:solidFill>
+            <a:prstDash val="solid"/>
+          </a:ln>
+        </p:spPr>
+      </p:sp>
+      <p:sp>
+        <p:nvSpPr>
+          <p:cNvPr id="22" name="Text 20"/>
+          <p:cNvSpPr/>
+          <p:nvPr/>
+        </p:nvSpPr>
+        <p:spPr>
+          <a:xfrm>
+            <a:off x="877824" y="4000500"/>
+            <a:ext cx="256032" cy="91440"/>
           </a:xfrm>
           <a:prstGeom prst="rect">
             <a:avLst/>
@@ -1527,7 +1610,7 @@
               <a:buNone/>
             </a:pPr>
             <a:r>
-              <a:rPr lang="en-US" sz="650" b="1" spc="80" kern="0" dirty="0">
+              <a:rPr lang="en-US" sz="480" b="1" spc="50" kern="0" dirty="0">
                 <a:solidFill>
                   <a:srgbClr val="FFFFFF"/>
                 </a:solidFill>
@@ -1537,20 +1620,20 @@
               </a:rPr>
               <a:t>03</a:t>
             </a:r>
-            <a:endParaRPr lang="en-US" sz="650" dirty="0"/>
-          </a:p>
-        </p:txBody>
-      </p:sp>
-      <p:sp>
-        <p:nvSpPr>
-          <p:cNvPr id="20" name="Text 18"/>
-          <p:cNvSpPr/>
-          <p:nvPr/>
-        </p:nvSpPr>
-        <p:spPr>
-          <a:xfrm>
-            <a:off x="8769096" y="2084832"/>
-            <a:ext cx="256032" cy="164592"/>
+            <a:endParaRPr lang="en-US" sz="480" dirty="0"/>
+          </a:p>
+        </p:txBody>
+      </p:sp>
+      <p:sp>
+        <p:nvSpPr>
+          <p:cNvPr id="23" name="Text 21"/>
+          <p:cNvSpPr/>
+          <p:nvPr/>
+        </p:nvSpPr>
+        <p:spPr>
+          <a:xfrm>
+            <a:off x="1243584" y="4000500"/>
+            <a:ext cx="3017520" cy="109728"/>
           </a:xfrm>
           <a:prstGeom prst="rect">
             <a:avLst/>
@@ -1562,34 +1645,34 @@
           <a:bodyPr wrap="square" lIns="0" tIns="0" rIns="0" bIns="0" rtlCol="0" anchor="ctr"/>
           <a:lstStyle/>
           <a:p>
-            <a:pPr algn="ctr" indent="0" marL="0">
+            <a:pPr indent="0" marL="0">
               <a:buNone/>
             </a:pPr>
             <a:r>
-              <a:rPr lang="en-US" sz="900" dirty="0">
+              <a:rPr lang="en-US" sz="650" b="1" spc="110" kern="0" dirty="0">
                 <a:solidFill>
-                  <a:srgbClr val="1668E3"/>
+                  <a:srgbClr val="F4F2EC"/>
                 </a:solidFill>
                 <a:latin typeface="Arial" pitchFamily="34" charset="0"/>
                 <a:ea typeface="Arial" pitchFamily="34" charset="-122"/>
                 <a:cs typeface="Arial" pitchFamily="34" charset="-120"/>
               </a:rPr>
-              <a:t>→</a:t>
-            </a:r>
-            <a:endParaRPr lang="en-US" sz="900" dirty="0"/>
-          </a:p>
-        </p:txBody>
-      </p:sp>
-      <p:sp>
-        <p:nvSpPr>
-          <p:cNvPr id="21" name="Text 19"/>
-          <p:cNvSpPr/>
-          <p:nvPr/>
-        </p:nvSpPr>
-        <p:spPr>
-          <a:xfrm>
-            <a:off x="6236208" y="2761488"/>
-            <a:ext cx="2532888" cy="822960"/>
+              <a:t>EVIDENCE</a:t>
+            </a:r>
+            <a:endParaRPr lang="en-US" sz="650" dirty="0"/>
+          </a:p>
+        </p:txBody>
+      </p:sp>
+      <p:sp>
+        <p:nvSpPr>
+          <p:cNvPr id="24" name="Text 22"/>
+          <p:cNvSpPr/>
+          <p:nvPr/>
+        </p:nvSpPr>
+        <p:spPr>
+          <a:xfrm>
+            <a:off x="877824" y="4297680"/>
+            <a:ext cx="3401568" cy="658368"/>
           </a:xfrm>
           <a:prstGeom prst="rect">
             <a:avLst/>
@@ -1607,9 +1690,9 @@
               <a:buNone/>
             </a:pPr>
             <a:r>
-              <a:rPr lang="en-US" sz="1800" dirty="0">
+              <a:rPr lang="en-US" sz="1400" dirty="0">
                 <a:solidFill>
-                  <a:srgbClr val="171816"/>
+                  <a:srgbClr val="F4F2EC"/>
                 </a:solidFill>
                 <a:latin typeface="Arial" pitchFamily="34" charset="0"/>
                 <a:ea typeface="Arial" pitchFamily="34" charset="-122"/>
@@ -1617,20 +1700,20 @@
               </a:rPr>
               <a:t>Every factual claim retains an exact source locator</a:t>
             </a:r>
-            <a:endParaRPr lang="en-US" sz="1800" dirty="0"/>
-          </a:p>
-        </p:txBody>
-      </p:sp>
-      <p:sp>
-        <p:nvSpPr>
-          <p:cNvPr id="22" name="Text 20"/>
-          <p:cNvSpPr/>
-          <p:nvPr/>
-        </p:nvSpPr>
-        <p:spPr>
-          <a:xfrm>
-            <a:off x="6236208" y="3785616"/>
-            <a:ext cx="2532888" cy="1143000"/>
+            <a:endParaRPr lang="en-US" sz="1400" dirty="0"/>
+          </a:p>
+        </p:txBody>
+      </p:sp>
+      <p:sp>
+        <p:nvSpPr>
+          <p:cNvPr id="25" name="Text 23"/>
+          <p:cNvSpPr/>
+          <p:nvPr/>
+        </p:nvSpPr>
+        <p:spPr>
+          <a:xfrm>
+            <a:off x="877824" y="5029200"/>
+            <a:ext cx="3401568" cy="566928"/>
           </a:xfrm>
           <a:prstGeom prst="rect">
             <a:avLst/>
@@ -1648,9 +1731,9 @@
               <a:buNone/>
             </a:pPr>
             <a:r>
-              <a:rPr lang="en-US" sz="1100" dirty="0">
+              <a:rPr lang="en-US" sz="850" dirty="0">
                 <a:solidFill>
-                  <a:srgbClr val="171816">
+                  <a:srgbClr val="F4F2EC">
                     <a:alpha val="72000"/>
                   </a:srgbClr>
                 </a:solidFill>
@@ -1660,20 +1743,20 @@
               </a:rPr>
               <a:t>so evidence stays inspectable from the editable Map through the final presentation and Storyboard</a:t>
             </a:r>
-            <a:endParaRPr lang="en-US" sz="1100" dirty="0"/>
-          </a:p>
-        </p:txBody>
-      </p:sp>
-      <p:sp>
-        <p:nvSpPr>
-          <p:cNvPr id="23" name="Text 21"/>
-          <p:cNvSpPr/>
-          <p:nvPr/>
-        </p:nvSpPr>
-        <p:spPr>
-          <a:xfrm>
-            <a:off x="6236208" y="5907024"/>
-            <a:ext cx="2532888" cy="164592"/>
+            <a:endParaRPr lang="en-US" sz="850" dirty="0"/>
+          </a:p>
+        </p:txBody>
+      </p:sp>
+      <p:sp>
+        <p:nvSpPr>
+          <p:cNvPr id="26" name="Text 24"/>
+          <p:cNvSpPr/>
+          <p:nvPr/>
+        </p:nvSpPr>
+        <p:spPr>
+          <a:xfrm>
+            <a:off x="877824" y="5687568"/>
+            <a:ext cx="3401568" cy="91440"/>
           </a:xfrm>
           <a:prstGeom prst="rect">
             <a:avLst/>
@@ -1691,9 +1774,9 @@
               <a:buNone/>
             </a:pPr>
             <a:r>
-              <a:rPr lang="en-US" sz="650" dirty="0">
+              <a:rPr lang="en-US" sz="520" dirty="0">
                 <a:solidFill>
-                  <a:srgbClr val="171816">
+                  <a:srgbClr val="F4F2EC">
                     <a:alpha val="58000"/>
                   </a:srgbClr>
                 </a:solidFill>
@@ -1703,30 +1786,30 @@
               </a:rPr>
               <a:t>Source: Recorded fixture brainstorm</a:t>
             </a:r>
-            <a:endParaRPr lang="en-US" sz="650" dirty="0"/>
-          </a:p>
-        </p:txBody>
-      </p:sp>
-      <p:sp>
-        <p:nvSpPr>
-          <p:cNvPr id="24" name="Shape 22"/>
-          <p:cNvSpPr/>
-          <p:nvPr/>
-        </p:nvSpPr>
-        <p:spPr>
-          <a:xfrm>
-            <a:off x="9025128" y="1975104"/>
-            <a:ext cx="438912" cy="438912"/>
-          </a:xfrm>
-          <a:prstGeom prst="ellipse">
+            <a:endParaRPr lang="en-US" sz="520" dirty="0"/>
+          </a:p>
+        </p:txBody>
+      </p:sp>
+      <p:sp>
+        <p:nvSpPr>
+          <p:cNvPr id="27" name="Shape 25"/>
+          <p:cNvSpPr/>
+          <p:nvPr/>
+        </p:nvSpPr>
+        <p:spPr>
+          <a:xfrm>
+            <a:off x="4718304" y="3767328"/>
+            <a:ext cx="6830568" cy="2139696"/>
+          </a:xfrm>
+          <a:prstGeom prst="rect">
             <a:avLst/>
           </a:prstGeom>
           <a:solidFill>
             <a:srgbClr val="1668E3"/>
           </a:solidFill>
-          <a:ln w="50800">
+          <a:ln w="10160">
             <a:solidFill>
-              <a:srgbClr val="F4F2EC"/>
+              <a:srgbClr val="1668E3"/>
             </a:solidFill>
             <a:prstDash val="solid"/>
           </a:ln>
@@ -1734,14 +1817,41 @@
       </p:sp>
       <p:sp>
         <p:nvSpPr>
-          <p:cNvPr id="25" name="Text 23"/>
-          <p:cNvSpPr/>
-          <p:nvPr/>
-        </p:nvSpPr>
-        <p:spPr>
-          <a:xfrm>
-            <a:off x="9025128" y="2093976"/>
-            <a:ext cx="438912" cy="118872"/>
+          <p:cNvPr id="28" name="Shape 26"/>
+          <p:cNvSpPr/>
+          <p:nvPr/>
+        </p:nvSpPr>
+        <p:spPr>
+          <a:xfrm>
+            <a:off x="4937760" y="3922776"/>
+            <a:ext cx="256032" cy="256032"/>
+          </a:xfrm>
+          <a:prstGeom prst="ellipse">
+            <a:avLst/>
+          </a:prstGeom>
+          <a:solidFill>
+            <a:srgbClr val="FFFFFF"/>
+          </a:solidFill>
+          <a:ln w="12700">
+            <a:solidFill>
+              <a:srgbClr val="FFFFFF">
+                <a:alpha val="0"/>
+              </a:srgbClr>
+            </a:solidFill>
+            <a:prstDash val="solid"/>
+          </a:ln>
+        </p:spPr>
+      </p:sp>
+      <p:sp>
+        <p:nvSpPr>
+          <p:cNvPr id="29" name="Text 27"/>
+          <p:cNvSpPr/>
+          <p:nvPr/>
+        </p:nvSpPr>
+        <p:spPr>
+          <a:xfrm>
+            <a:off x="4937760" y="4000500"/>
+            <a:ext cx="256032" cy="91440"/>
           </a:xfrm>
           <a:prstGeom prst="rect">
             <a:avLst/>
@@ -1757,7 +1867,46 @@
               <a:buNone/>
             </a:pPr>
             <a:r>
-              <a:rPr lang="en-US" sz="650" b="1" spc="80" kern="0" dirty="0">
+              <a:rPr lang="en-US" sz="480" b="1" spc="50" kern="0" dirty="0">
+                <a:solidFill>
+                  <a:srgbClr val="1668E3"/>
+                </a:solidFill>
+                <a:latin typeface="Arial" pitchFamily="34" charset="0"/>
+                <a:ea typeface="Arial" pitchFamily="34" charset="-122"/>
+                <a:cs typeface="Arial" pitchFamily="34" charset="-120"/>
+              </a:rPr>
+              <a:t>04</a:t>
+            </a:r>
+            <a:endParaRPr lang="en-US" sz="480" dirty="0"/>
+          </a:p>
+        </p:txBody>
+      </p:sp>
+      <p:sp>
+        <p:nvSpPr>
+          <p:cNvPr id="30" name="Text 28"/>
+          <p:cNvSpPr/>
+          <p:nvPr/>
+        </p:nvSpPr>
+        <p:spPr>
+          <a:xfrm>
+            <a:off x="5303520" y="4000500"/>
+            <a:ext cx="6007608" cy="109728"/>
+          </a:xfrm>
+          <a:prstGeom prst="rect">
+            <a:avLst/>
+          </a:prstGeom>
+          <a:noFill/>
+          <a:ln/>
+        </p:spPr>
+        <p:txBody>
+          <a:bodyPr wrap="square" lIns="0" tIns="0" rIns="0" bIns="0" rtlCol="0" anchor="ctr"/>
+          <a:lstStyle/>
+          <a:p>
+            <a:pPr indent="0" marL="0">
+              <a:buNone/>
+            </a:pPr>
+            <a:r>
+              <a:rPr lang="en-US" sz="650" b="1" spc="110" kern="0" dirty="0">
                 <a:solidFill>
                   <a:srgbClr val="FFFFFF"/>
                 </a:solidFill>
@@ -1765,7 +1914,7 @@
                 <a:ea typeface="Arial" pitchFamily="34" charset="-122"/>
                 <a:cs typeface="Arial" pitchFamily="34" charset="-120"/>
               </a:rPr>
-              <a:t>04</a:t>
+              <a:t>RECOMMENDATION</a:t>
             </a:r>
             <a:endParaRPr lang="en-US" sz="650" dirty="0"/>
           </a:p>
@@ -1773,14 +1922,14 @@
       </p:sp>
       <p:sp>
         <p:nvSpPr>
-          <p:cNvPr id="26" name="Text 24"/>
-          <p:cNvSpPr/>
-          <p:nvPr/>
-        </p:nvSpPr>
-        <p:spPr>
-          <a:xfrm>
-            <a:off x="9025128" y="2761488"/>
-            <a:ext cx="2532888" cy="822960"/>
+          <p:cNvPr id="31" name="Text 29"/>
+          <p:cNvSpPr/>
+          <p:nvPr/>
+        </p:nvSpPr>
+        <p:spPr>
+          <a:xfrm>
+            <a:off x="4937760" y="4297680"/>
+            <a:ext cx="6391656" cy="658368"/>
           </a:xfrm>
           <a:prstGeom prst="rect">
             <a:avLst/>
@@ -1798,9 +1947,9 @@
               <a:buNone/>
             </a:pPr>
             <a:r>
-              <a:rPr lang="en-US" sz="1800" dirty="0">
+              <a:rPr lang="en-US" sz="1900" dirty="0">
                 <a:solidFill>
-                  <a:srgbClr val="171816"/>
+                  <a:srgbClr val="FFFFFF"/>
                 </a:solidFill>
                 <a:latin typeface="Arial" pitchFamily="34" charset="0"/>
                 <a:ea typeface="Arial" pitchFamily="34" charset="-122"/>
@@ -1808,20 +1957,20 @@
               </a:rPr>
               <a:t>Teams should use two deliberate sign-offs</a:t>
             </a:r>
-            <a:endParaRPr lang="en-US" sz="1800" dirty="0"/>
-          </a:p>
-        </p:txBody>
-      </p:sp>
-      <p:sp>
-        <p:nvSpPr>
-          <p:cNvPr id="27" name="Text 25"/>
-          <p:cNvSpPr/>
-          <p:nvPr/>
-        </p:nvSpPr>
-        <p:spPr>
-          <a:xfrm>
-            <a:off x="9025128" y="3785616"/>
-            <a:ext cx="2532888" cy="1143000"/>
+            <a:endParaRPr lang="en-US" sz="1900" dirty="0"/>
+          </a:p>
+        </p:txBody>
+      </p:sp>
+      <p:sp>
+        <p:nvSpPr>
+          <p:cNvPr id="32" name="Text 30"/>
+          <p:cNvSpPr/>
+          <p:nvPr/>
+        </p:nvSpPr>
+        <p:spPr>
+          <a:xfrm>
+            <a:off x="4937760" y="5029200"/>
+            <a:ext cx="6391656" cy="566928"/>
           </a:xfrm>
           <a:prstGeom prst="rect">
             <a:avLst/>
@@ -1839,10 +1988,10 @@
               <a:buNone/>
             </a:pPr>
             <a:r>
-              <a:rPr lang="en-US" sz="1100" dirty="0">
+              <a:rPr lang="en-US" sz="1000" dirty="0">
                 <a:solidFill>
-                  <a:srgbClr val="171816">
-                    <a:alpha val="72000"/>
+                  <a:srgbClr val="FFFFFF">
+                    <a:alpha val="92000"/>
                   </a:srgbClr>
                 </a:solidFill>
                 <a:latin typeface="Arial" pitchFamily="34" charset="0"/>
@@ -1851,20 +2000,20 @@
               </a:rPr>
               <a:t>Approve the grounded Brief before creating professional knowledge work, then approve the Storyboard before rendering Video</a:t>
             </a:r>
-            <a:endParaRPr lang="en-US" sz="1100" dirty="0"/>
-          </a:p>
-        </p:txBody>
-      </p:sp>
-      <p:sp>
-        <p:nvSpPr>
-          <p:cNvPr id="28" name="Text 26"/>
-          <p:cNvSpPr/>
-          <p:nvPr/>
-        </p:nvSpPr>
-        <p:spPr>
-          <a:xfrm>
-            <a:off x="9025128" y="5907024"/>
-            <a:ext cx="2532888" cy="164592"/>
+            <a:endParaRPr lang="en-US" sz="1000" dirty="0"/>
+          </a:p>
+        </p:txBody>
+      </p:sp>
+      <p:sp>
+        <p:nvSpPr>
+          <p:cNvPr id="33" name="Text 31"/>
+          <p:cNvSpPr/>
+          <p:nvPr/>
+        </p:nvSpPr>
+        <p:spPr>
+          <a:xfrm>
+            <a:off x="4937760" y="5687568"/>
+            <a:ext cx="6391656" cy="91440"/>
           </a:xfrm>
           <a:prstGeom prst="rect">
             <a:avLst/>
@@ -1882,10 +2031,10 @@
               <a:buNone/>
             </a:pPr>
             <a:r>
-              <a:rPr lang="en-US" sz="650" dirty="0">
+              <a:rPr lang="en-US" sz="520" dirty="0">
                 <a:solidFill>
-                  <a:srgbClr val="171816">
-                    <a:alpha val="58000"/>
+                  <a:srgbClr val="FFFFFF">
+                    <a:alpha val="90000"/>
                   </a:srgbClr>
                 </a:solidFill>
                 <a:latin typeface="Arial" pitchFamily="34" charset="0"/>
@@ -1894,13 +2043,13 @@
               </a:rPr>
               <a:t>Source: Recorded fixture brainstorm</a:t>
             </a:r>
-            <a:endParaRPr lang="en-US" sz="650" dirty="0"/>
-          </a:p>
-        </p:txBody>
-      </p:sp>
-      <p:sp>
-        <p:nvSpPr>
-          <p:cNvPr id="30" name="Text 27"/>
+            <a:endParaRPr lang="en-US" sz="520" dirty="0"/>
+          </a:p>
+        </p:txBody>
+      </p:sp>
+      <p:sp>
+        <p:nvSpPr>
+          <p:cNvPr id="35" name="Text 32"/>
           <p:cNvSpPr/>
           <p:nvPr/>
         </p:nvSpPr>

</xml_diff>